<commit_message>
Verify translation deliverables and publish submission links
</commit_message>
<xml_diff>
--- a/output/Darija_Translation_Presentation.pptx
+++ b/output/Darija_Translation_Presentation.pptx
@@ -2,22 +2,22 @@
 <file path=ppt/presentation.xml><?xml version="1.0" encoding="utf-8"?>
 <p:presentation xmlns:p="http://schemas.openxmlformats.org/presentationml/2006/main">
   <p:sldMasterIdLst>
-    <p:sldMasterId xmlns:r="http://schemas.openxmlformats.org/officeDocument/2006/relationships" id="2147483648" r:id="R8ff2c83d56a84773"/>
+    <p:sldMasterId xmlns:r="http://schemas.openxmlformats.org/officeDocument/2006/relationships" id="2147483648" r:id="Rea467088144341ec"/>
   </p:sldMasterIdLst>
   <p:notesMasterIdLst>
-    <p:notesMasterId xmlns:r="http://schemas.openxmlformats.org/officeDocument/2006/relationships" r:id="Ra782b0850e1a4f8c"/>
+    <p:notesMasterId xmlns:r="http://schemas.openxmlformats.org/officeDocument/2006/relationships" r:id="R53cb881128044f10"/>
   </p:notesMasterIdLst>
   <p:sldIdLst>
-    <p:sldId xmlns:r="http://schemas.openxmlformats.org/officeDocument/2006/relationships" id="256" r:id="R86ea04598cdf4935"/>
-    <p:sldId xmlns:r="http://schemas.openxmlformats.org/officeDocument/2006/relationships" id="257" r:id="R484efd3570b543e4"/>
-    <p:sldId xmlns:r="http://schemas.openxmlformats.org/officeDocument/2006/relationships" id="258" r:id="R0d4b6141beac4ffa"/>
-    <p:sldId xmlns:r="http://schemas.openxmlformats.org/officeDocument/2006/relationships" id="259" r:id="Rc221b5d66e3c4d18"/>
-    <p:sldId xmlns:r="http://schemas.openxmlformats.org/officeDocument/2006/relationships" id="260" r:id="R4f07d2cfae604a13"/>
-    <p:sldId xmlns:r="http://schemas.openxmlformats.org/officeDocument/2006/relationships" id="261" r:id="R8e408da67d25429e"/>
-    <p:sldId xmlns:r="http://schemas.openxmlformats.org/officeDocument/2006/relationships" id="262" r:id="R14a896164b184dbb"/>
-    <p:sldId xmlns:r="http://schemas.openxmlformats.org/officeDocument/2006/relationships" id="263" r:id="R56c1cf24b8c6430c"/>
-    <p:sldId xmlns:r="http://schemas.openxmlformats.org/officeDocument/2006/relationships" id="264" r:id="Rfeb0d7d382474f1b"/>
-    <p:sldId xmlns:r="http://schemas.openxmlformats.org/officeDocument/2006/relationships" id="265" r:id="R6867742328d34d94"/>
+    <p:sldId xmlns:r="http://schemas.openxmlformats.org/officeDocument/2006/relationships" id="256" r:id="R022155e4a8af48bc"/>
+    <p:sldId xmlns:r="http://schemas.openxmlformats.org/officeDocument/2006/relationships" id="257" r:id="R5e60e976b836469a"/>
+    <p:sldId xmlns:r="http://schemas.openxmlformats.org/officeDocument/2006/relationships" id="258" r:id="R869e2e19466f42cf"/>
+    <p:sldId xmlns:r="http://schemas.openxmlformats.org/officeDocument/2006/relationships" id="259" r:id="R3aaada66c55046e7"/>
+    <p:sldId xmlns:r="http://schemas.openxmlformats.org/officeDocument/2006/relationships" id="260" r:id="R7987f324d4f54200"/>
+    <p:sldId xmlns:r="http://schemas.openxmlformats.org/officeDocument/2006/relationships" id="261" r:id="Rbf890902984b49d7"/>
+    <p:sldId xmlns:r="http://schemas.openxmlformats.org/officeDocument/2006/relationships" id="262" r:id="R09c4e71b95934578"/>
+    <p:sldId xmlns:r="http://schemas.openxmlformats.org/officeDocument/2006/relationships" id="263" r:id="R0249321572904c13"/>
+    <p:sldId xmlns:r="http://schemas.openxmlformats.org/officeDocument/2006/relationships" id="264" r:id="Rae2ba3b36a9b4e7a"/>
+    <p:sldId xmlns:r="http://schemas.openxmlformats.org/officeDocument/2006/relationships" id="265" r:id="R08fa81a64bc8402c"/>
   </p:sldIdLst>
   <p:sldSz cx="12192000" cy="6858000"/>
   <p:notesSz cx="6858000" cy="9144000"/>
@@ -526,7 +526,7 @@
           <a:lstStyle xmlns:a="http://schemas.openxmlformats.org/drawingml/2006/main"/>
           <a:p xmlns:a="http://schemas.openxmlformats.org/drawingml/2006/main">
             <a:r>
-              <a:t>40 seconds. More seeds and training are needed before stronger architecture claims. More verified parallel data is the main data constraint. Evaluate alternative BPE sizes, larger states, beam search and teacher-forcing schedules. Multiple Darija references and spelling-aware analysis would strengthen evaluation. All six presentation topics requested by the professor are covered. Total planned duration is ten minutes.</a:t>
+              <a:t>40 seconds. More seeds and training are needed before stronger architecture claims. More verified parallel data is the main data constraint. Evaluate alternative BPE sizes, larger states, beam search and teacher-forcing schedules. Multiple Darija references and spelling-aware analysis would strengthen evaluation. Discuss how these changes would be evaluated under the same fair comparison protocol.</a:t>
             </a:r>
           </a:p>
           <a:p xmlns:a="http://schemas.openxmlformats.org/drawingml/2006/main">
@@ -1178,7 +1178,7 @@
           <p:cNvPr id="3" name="Title">
             <a:extLst xmlns:a="http://schemas.openxmlformats.org/drawingml/2006/main">
               <a:ext uri="{FF2B5EF4-FFF2-40B4-BE49-F238E27FC236}">
-                <a16:creationId xmlns:a16="http://schemas.microsoft.com/office/drawing/2014/main" id="{A842ADA6-F601-48E7-B11B-C7A15A82B34A}"/>
+                <a16:creationId xmlns:a16="http://schemas.microsoft.com/office/drawing/2014/main" id="{8E78071D-D349-482A-9ABD-FC8B7A22F463}"/>
               </a:ext>
             </a:extLst>
           </p:cNvPr>
@@ -1407,7 +1407,7 @@
           <p:cNvPr id="2" name="Subtitle">
             <a:extLst xmlns:a="http://schemas.openxmlformats.org/drawingml/2006/main">
               <a:ext uri="{FF2B5EF4-FFF2-40B4-BE49-F238E27FC236}">
-                <a16:creationId xmlns:a16="http://schemas.microsoft.com/office/drawing/2014/main" id="{26D3C8A2-C251-4A23-A0DE-D2DE71A5107A}"/>
+                <a16:creationId xmlns:a16="http://schemas.microsoft.com/office/drawing/2014/main" id="{E473CACD-09AB-4D2F-84D9-3B3E3E198D69}"/>
               </a:ext>
             </a:extLst>
           </p:cNvPr>
@@ -1653,7 +1653,7 @@
           <p:cNvPr id="2" name="Section title">
             <a:extLst xmlns:a="http://schemas.openxmlformats.org/drawingml/2006/main">
               <a:ext uri="{FF2B5EF4-FFF2-40B4-BE49-F238E27FC236}">
-                <a16:creationId xmlns:a16="http://schemas.microsoft.com/office/drawing/2014/main" id="{B2D254E1-51B2-4AE5-BB35-F53E20C7275A}"/>
+                <a16:creationId xmlns:a16="http://schemas.microsoft.com/office/drawing/2014/main" id="{8724824B-E081-4356-96F4-ED4DA3020F33}"/>
               </a:ext>
             </a:extLst>
           </p:cNvPr>
@@ -1899,7 +1899,7 @@
           <p:cNvPr id="3" name="Title">
             <a:extLst xmlns:a="http://schemas.openxmlformats.org/drawingml/2006/main">
               <a:ext uri="{FF2B5EF4-FFF2-40B4-BE49-F238E27FC236}">
-                <a16:creationId xmlns:a16="http://schemas.microsoft.com/office/drawing/2014/main" id="{4B9DC0B0-D944-47D5-8F5F-B5D974062855}"/>
+                <a16:creationId xmlns:a16="http://schemas.microsoft.com/office/drawing/2014/main" id="{4C8AA3C9-E63E-4CFE-A90B-34768B2607DE}"/>
               </a:ext>
             </a:extLst>
           </p:cNvPr>
@@ -2128,7 +2128,7 @@
           <p:cNvPr id="2" name="Body">
             <a:extLst xmlns:a="http://schemas.openxmlformats.org/drawingml/2006/main">
               <a:ext uri="{FF2B5EF4-FFF2-40B4-BE49-F238E27FC236}">
-                <a16:creationId xmlns:a16="http://schemas.microsoft.com/office/drawing/2014/main" id="{133DC4F1-3911-4602-B002-F1C881404BE5}"/>
+                <a16:creationId xmlns:a16="http://schemas.microsoft.com/office/drawing/2014/main" id="{9D04A4B2-F3C2-46A0-BE08-A32C30479595}"/>
               </a:ext>
             </a:extLst>
           </p:cNvPr>
@@ -2374,7 +2374,7 @@
           <p:cNvPr id="4" name="Title">
             <a:extLst xmlns:a="http://schemas.openxmlformats.org/drawingml/2006/main">
               <a:ext uri="{FF2B5EF4-FFF2-40B4-BE49-F238E27FC236}">
-                <a16:creationId xmlns:a16="http://schemas.microsoft.com/office/drawing/2014/main" id="{AE06D445-FB2D-4AD8-9679-92BC612A4913}"/>
+                <a16:creationId xmlns:a16="http://schemas.microsoft.com/office/drawing/2014/main" id="{33C9DC77-76CF-4DA7-8593-4E3B89AABBE5}"/>
               </a:ext>
             </a:extLst>
           </p:cNvPr>
@@ -2603,7 +2603,7 @@
           <p:cNvPr id="2" name="Left column">
             <a:extLst xmlns:a="http://schemas.openxmlformats.org/drawingml/2006/main">
               <a:ext uri="{FF2B5EF4-FFF2-40B4-BE49-F238E27FC236}">
-                <a16:creationId xmlns:a16="http://schemas.microsoft.com/office/drawing/2014/main" id="{05CEA72E-A78C-417D-8785-92CC86768712}"/>
+                <a16:creationId xmlns:a16="http://schemas.microsoft.com/office/drawing/2014/main" id="{F49A988B-316A-4D39-AC4D-AA1B3BF8F851}"/>
               </a:ext>
             </a:extLst>
           </p:cNvPr>
@@ -2832,7 +2832,7 @@
           <p:cNvPr id="3" name="Right column">
             <a:extLst xmlns:a="http://schemas.openxmlformats.org/drawingml/2006/main">
               <a:ext uri="{FF2B5EF4-FFF2-40B4-BE49-F238E27FC236}">
-                <a16:creationId xmlns:a16="http://schemas.microsoft.com/office/drawing/2014/main" id="{0A2D9B4A-5000-4506-94D1-E67156D61273}"/>
+                <a16:creationId xmlns:a16="http://schemas.microsoft.com/office/drawing/2014/main" id="{4E1FD59A-8D5C-4B0D-BED1-044D530AD403}"/>
               </a:ext>
             </a:extLst>
           </p:cNvPr>
@@ -3078,7 +3078,7 @@
           <p:cNvPr id="3" name="Title">
             <a:extLst xmlns:a="http://schemas.openxmlformats.org/drawingml/2006/main">
               <a:ext uri="{FF2B5EF4-FFF2-40B4-BE49-F238E27FC236}">
-                <a16:creationId xmlns:a16="http://schemas.microsoft.com/office/drawing/2014/main" id="{D40CB3C3-C9E3-4C28-AA8A-F253BA5CD627}"/>
+                <a16:creationId xmlns:a16="http://schemas.microsoft.com/office/drawing/2014/main" id="{2B8AB75D-3089-40ED-8E75-44D9AC822234}"/>
               </a:ext>
             </a:extLst>
           </p:cNvPr>
@@ -3307,7 +3307,7 @@
           <p:cNvPr id="2" name="Left column">
             <a:extLst xmlns:a="http://schemas.openxmlformats.org/drawingml/2006/main">
               <a:ext uri="{FF2B5EF4-FFF2-40B4-BE49-F238E27FC236}">
-                <a16:creationId xmlns:a16="http://schemas.microsoft.com/office/drawing/2014/main" id="{554924D5-2915-4F04-83FE-3E76FDC4BF74}"/>
+                <a16:creationId xmlns:a16="http://schemas.microsoft.com/office/drawing/2014/main" id="{BAF266ED-9B73-4A14-AAE3-514C91C120D9}"/>
               </a:ext>
             </a:extLst>
           </p:cNvPr>
@@ -3574,12 +3574,12 @@
   </p:cSld>
   <p:clrMap bg1="lt1" tx1="dk1" bg2="lt2" tx2="dk2" accent1="accent1" accent2="accent2" accent3="accent3" accent4="accent4" accent5="accent5" accent6="accent6" hlink="hlink" folHlink="folHlink"/>
   <p:sldLayoutIdLst>
-    <p:sldLayoutId xmlns:r="http://schemas.openxmlformats.org/officeDocument/2006/relationships" id="2147483649" r:id="R1a4de245e2b341b9"/>
-    <p:sldLayoutId xmlns:r="http://schemas.openxmlformats.org/officeDocument/2006/relationships" id="2147483650" r:id="R735c5e2e248245a7"/>
-    <p:sldLayoutId xmlns:r="http://schemas.openxmlformats.org/officeDocument/2006/relationships" id="2147483651" r:id="R17a2d511c21b4652"/>
-    <p:sldLayoutId xmlns:r="http://schemas.openxmlformats.org/officeDocument/2006/relationships" id="2147483652" r:id="R42db6e3d93234627"/>
-    <p:sldLayoutId xmlns:r="http://schemas.openxmlformats.org/officeDocument/2006/relationships" id="2147483653" r:id="R01af596263554ea9"/>
-    <p:sldLayoutId xmlns:r="http://schemas.openxmlformats.org/officeDocument/2006/relationships" id="2147483654" r:id="R01d4724b77234eaf"/>
+    <p:sldLayoutId xmlns:r="http://schemas.openxmlformats.org/officeDocument/2006/relationships" id="2147483649" r:id="R48943c9ffc774747"/>
+    <p:sldLayoutId xmlns:r="http://schemas.openxmlformats.org/officeDocument/2006/relationships" id="2147483650" r:id="R3d2f7048f05942d1"/>
+    <p:sldLayoutId xmlns:r="http://schemas.openxmlformats.org/officeDocument/2006/relationships" id="2147483651" r:id="R37877c55fb024223"/>
+    <p:sldLayoutId xmlns:r="http://schemas.openxmlformats.org/officeDocument/2006/relationships" id="2147483652" r:id="R9f94e6e1c37f427d"/>
+    <p:sldLayoutId xmlns:r="http://schemas.openxmlformats.org/officeDocument/2006/relationships" id="2147483653" r:id="R65f41af7ce464d35"/>
+    <p:sldLayoutId xmlns:r="http://schemas.openxmlformats.org/officeDocument/2006/relationships" id="2147483654" r:id="Rab5c9825007d416f"/>
   </p:sldLayoutIdLst>
   <p:txStyles>
     <p:titleStyle>
@@ -5079,7 +5079,7 @@
           <p:cNvPr id="8" name="">
             <a:extLst xmlns:a="http://schemas.openxmlformats.org/drawingml/2006/main">
               <a:ext uri="{FF2B5EF4-FFF2-40B4-BE49-F238E27FC236}">
-                <a16:creationId xmlns:a16="http://schemas.microsoft.com/office/drawing/2014/main" id="{0A87F37F-87DA-47DC-B260-7AF74558C69C}"/>
+                <a16:creationId xmlns:a16="http://schemas.microsoft.com/office/drawing/2014/main" id="{469346E2-2826-4E2D-B2ED-29BE8ECD5B19}"/>
               </a:ext>
             </a:extLst>
           </p:cNvPr>
@@ -5235,7 +5235,7 @@
           <p:cNvPr id="2" name="">
             <a:extLst xmlns:a="http://schemas.openxmlformats.org/drawingml/2006/main">
               <a:ext uri="{FF2B5EF4-FFF2-40B4-BE49-F238E27FC236}">
-                <a16:creationId xmlns:a16="http://schemas.microsoft.com/office/drawing/2014/main" id="{782BDB5E-E74D-4C0F-BD4E-8A9DC4AAB131}"/>
+                <a16:creationId xmlns:a16="http://schemas.microsoft.com/office/drawing/2014/main" id="{7BB4D7D8-E40F-4835-9178-D698DF04D6D4}"/>
               </a:ext>
             </a:extLst>
           </p:cNvPr>
@@ -5414,7 +5414,7 @@
           <p:cNvPr id="3" name="">
             <a:extLst xmlns:a="http://schemas.openxmlformats.org/drawingml/2006/main">
               <a:ext uri="{FF2B5EF4-FFF2-40B4-BE49-F238E27FC236}">
-                <a16:creationId xmlns:a16="http://schemas.microsoft.com/office/drawing/2014/main" id="{94179EB7-F84A-4CE2-A047-CA81C98168EF}"/>
+                <a16:creationId xmlns:a16="http://schemas.microsoft.com/office/drawing/2014/main" id="{E1627810-5B3D-4F0D-A5F2-70541F47AD7A}"/>
               </a:ext>
             </a:extLst>
           </p:cNvPr>
@@ -5570,7 +5570,7 @@
           <p:cNvPr id="4" name="">
             <a:extLst xmlns:a="http://schemas.openxmlformats.org/drawingml/2006/main">
               <a:ext uri="{FF2B5EF4-FFF2-40B4-BE49-F238E27FC236}">
-                <a16:creationId xmlns:a16="http://schemas.microsoft.com/office/drawing/2014/main" id="{628F9FC1-B8B8-428E-86BC-854EFD1D8514}"/>
+                <a16:creationId xmlns:a16="http://schemas.microsoft.com/office/drawing/2014/main" id="{CBA99302-330B-44AC-B2D6-90C7B536E60C}"/>
               </a:ext>
             </a:extLst>
           </p:cNvPr>
@@ -5726,7 +5726,7 @@
           <p:cNvPr id="5" name="">
             <a:extLst xmlns:a="http://schemas.openxmlformats.org/drawingml/2006/main">
               <a:ext uri="{FF2B5EF4-FFF2-40B4-BE49-F238E27FC236}">
-                <a16:creationId xmlns:a16="http://schemas.microsoft.com/office/drawing/2014/main" id="{3F683788-2FFF-4B26-AC92-3FB90365DBCF}"/>
+                <a16:creationId xmlns:a16="http://schemas.microsoft.com/office/drawing/2014/main" id="{4DE4A866-F676-40CC-9F33-0329B3181BA4}"/>
               </a:ext>
             </a:extLst>
           </p:cNvPr>
@@ -5951,7 +5951,7 @@
           <p:cNvPr id="6" name="">
             <a:extLst xmlns:a="http://schemas.openxmlformats.org/drawingml/2006/main">
               <a:ext uri="{FF2B5EF4-FFF2-40B4-BE49-F238E27FC236}">
-                <a16:creationId xmlns:a16="http://schemas.microsoft.com/office/drawing/2014/main" id="{F8DF5E1C-112F-41F6-B79D-79A22890AB52}"/>
+                <a16:creationId xmlns:a16="http://schemas.microsoft.com/office/drawing/2014/main" id="{DCE5C246-C1B7-40BE-A0E2-54830588188B}"/>
               </a:ext>
             </a:extLst>
           </p:cNvPr>
@@ -6130,7 +6130,7 @@
           <p:cNvPr id="7" name="">
             <a:extLst xmlns:a="http://schemas.openxmlformats.org/drawingml/2006/main">
               <a:ext uri="{FF2B5EF4-FFF2-40B4-BE49-F238E27FC236}">
-                <a16:creationId xmlns:a16="http://schemas.microsoft.com/office/drawing/2014/main" id="{16BA3E66-CFAB-418E-9AE4-24C3B4607808}"/>
+                <a16:creationId xmlns:a16="http://schemas.microsoft.com/office/drawing/2014/main" id="{6BF6C8EA-6187-4EF9-AA36-9B645CCAB8F6}"/>
               </a:ext>
             </a:extLst>
           </p:cNvPr>
@@ -6140,7 +6140,7 @@
           <p:nvPr/>
         </p:nvPicPr>
         <p:blipFill>
-          <a:blip xmlns:r="http://schemas.openxmlformats.org/officeDocument/2006/relationships" xmlns:a="http://schemas.openxmlformats.org/drawingml/2006/main" r:embed="Rff4b479dc2744e42"/>
+          <a:blip xmlns:r="http://schemas.openxmlformats.org/officeDocument/2006/relationships" xmlns:a="http://schemas.openxmlformats.org/drawingml/2006/main" r:embed="R55f9461595b74f69"/>
           <a:stretch xmlns:a="http://schemas.openxmlformats.org/drawingml/2006/main"/>
         </p:blipFill>
         <p:spPr>
@@ -6156,7 +6156,7 @@
     </p:spTree>
     <p:extLst>
       <p:ext uri="{BB962C8B-B14F-4D97-AF65-F5344CB8AC3E}">
-        <p14:creationId xmlns:p14="http://schemas.microsoft.com/office/powerpoint/2010/main" val="1552893936"/>
+        <p14:creationId xmlns:p14="http://schemas.microsoft.com/office/powerpoint/2010/main" val="1236297696"/>
       </p:ext>
     </p:extLst>
   </p:cSld>
@@ -6187,7 +6187,7 @@
           <p:cNvPr id="13" name="">
             <a:extLst xmlns:a="http://schemas.openxmlformats.org/drawingml/2006/main">
               <a:ext uri="{FF2B5EF4-FFF2-40B4-BE49-F238E27FC236}">
-                <a16:creationId xmlns:a16="http://schemas.microsoft.com/office/drawing/2014/main" id="{D9786D06-C04E-4FB7-A481-568142FF4A35}"/>
+                <a16:creationId xmlns:a16="http://schemas.microsoft.com/office/drawing/2014/main" id="{3A5A1208-64F5-407C-8992-52EE4ECDC27D}"/>
               </a:ext>
             </a:extLst>
           </p:cNvPr>
@@ -6343,7 +6343,7 @@
           <p:cNvPr id="2" name="">
             <a:extLst xmlns:a="http://schemas.openxmlformats.org/drawingml/2006/main">
               <a:ext uri="{FF2B5EF4-FFF2-40B4-BE49-F238E27FC236}">
-                <a16:creationId xmlns:a16="http://schemas.microsoft.com/office/drawing/2014/main" id="{3D69C9D8-3B2F-4A79-B1E0-F9AE904C62AB}"/>
+                <a16:creationId xmlns:a16="http://schemas.microsoft.com/office/drawing/2014/main" id="{6747D31B-6296-44BC-A457-57CB12C43FC3}"/>
               </a:ext>
             </a:extLst>
           </p:cNvPr>
@@ -6499,7 +6499,7 @@
           <p:cNvPr id="3" name="">
             <a:extLst xmlns:a="http://schemas.openxmlformats.org/drawingml/2006/main">
               <a:ext uri="{FF2B5EF4-FFF2-40B4-BE49-F238E27FC236}">
-                <a16:creationId xmlns:a16="http://schemas.microsoft.com/office/drawing/2014/main" id="{D530A64F-CBB5-4B63-B004-C6A11A56C789}"/>
+                <a16:creationId xmlns:a16="http://schemas.microsoft.com/office/drawing/2014/main" id="{45F80A5C-C6EC-4B4F-929A-11353FD52CE6}"/>
               </a:ext>
             </a:extLst>
           </p:cNvPr>
@@ -6655,7 +6655,7 @@
           <p:cNvPr id="4" name="">
             <a:extLst xmlns:a="http://schemas.openxmlformats.org/drawingml/2006/main">
               <a:ext uri="{FF2B5EF4-FFF2-40B4-BE49-F238E27FC236}">
-                <a16:creationId xmlns:a16="http://schemas.microsoft.com/office/drawing/2014/main" id="{DA4D407B-3C44-4BFE-AAC3-A2D4B26EDB2A}"/>
+                <a16:creationId xmlns:a16="http://schemas.microsoft.com/office/drawing/2014/main" id="{58A28F1D-58B7-4BE6-A3ED-BDA652AAF02C}"/>
               </a:ext>
             </a:extLst>
           </p:cNvPr>
@@ -6811,7 +6811,7 @@
           <p:cNvPr id="5" name="">
             <a:extLst xmlns:a="http://schemas.openxmlformats.org/drawingml/2006/main">
               <a:ext uri="{FF2B5EF4-FFF2-40B4-BE49-F238E27FC236}">
-                <a16:creationId xmlns:a16="http://schemas.microsoft.com/office/drawing/2014/main" id="{D203B764-0E82-4ACC-822B-E882403D2F98}"/>
+                <a16:creationId xmlns:a16="http://schemas.microsoft.com/office/drawing/2014/main" id="{6B75ED7F-0392-479E-8D0D-A5D2BE96C017}"/>
               </a:ext>
             </a:extLst>
           </p:cNvPr>
@@ -6967,7 +6967,7 @@
           <p:cNvPr id="6" name="">
             <a:extLst xmlns:a="http://schemas.openxmlformats.org/drawingml/2006/main">
               <a:ext uri="{FF2B5EF4-FFF2-40B4-BE49-F238E27FC236}">
-                <a16:creationId xmlns:a16="http://schemas.microsoft.com/office/drawing/2014/main" id="{93158149-C570-404F-914B-8A0DBF62E6F7}"/>
+                <a16:creationId xmlns:a16="http://schemas.microsoft.com/office/drawing/2014/main" id="{F9029062-9CCB-4901-8CD0-123EBB4FA32C}"/>
               </a:ext>
             </a:extLst>
           </p:cNvPr>
@@ -7123,7 +7123,7 @@
           <p:cNvPr id="7" name="">
             <a:extLst xmlns:a="http://schemas.openxmlformats.org/drawingml/2006/main">
               <a:ext uri="{FF2B5EF4-FFF2-40B4-BE49-F238E27FC236}">
-                <a16:creationId xmlns:a16="http://schemas.microsoft.com/office/drawing/2014/main" id="{8AB79BE3-477C-4451-B98E-F13A7479A116}"/>
+                <a16:creationId xmlns:a16="http://schemas.microsoft.com/office/drawing/2014/main" id="{2943B73A-1279-4170-97D1-8C79D0074ACC}"/>
               </a:ext>
             </a:extLst>
           </p:cNvPr>
@@ -7279,7 +7279,7 @@
           <p:cNvPr id="8" name="">
             <a:extLst xmlns:a="http://schemas.openxmlformats.org/drawingml/2006/main">
               <a:ext uri="{FF2B5EF4-FFF2-40B4-BE49-F238E27FC236}">
-                <a16:creationId xmlns:a16="http://schemas.microsoft.com/office/drawing/2014/main" id="{F43D8E65-5556-495E-B5A4-16FC639AEA5D}"/>
+                <a16:creationId xmlns:a16="http://schemas.microsoft.com/office/drawing/2014/main" id="{09DD5DA2-E8C1-439C-9C8B-3EC225471AC1}"/>
               </a:ext>
             </a:extLst>
           </p:cNvPr>
@@ -7435,7 +7435,7 @@
           <p:cNvPr id="9" name="">
             <a:extLst xmlns:a="http://schemas.openxmlformats.org/drawingml/2006/main">
               <a:ext uri="{FF2B5EF4-FFF2-40B4-BE49-F238E27FC236}">
-                <a16:creationId xmlns:a16="http://schemas.microsoft.com/office/drawing/2014/main" id="{58A2FB17-8C1B-4617-BB9A-702FB9E29CA1}"/>
+                <a16:creationId xmlns:a16="http://schemas.microsoft.com/office/drawing/2014/main" id="{BB4242C4-E7D5-4CE9-8FD1-8E323A094B71}"/>
               </a:ext>
             </a:extLst>
           </p:cNvPr>
@@ -7591,7 +7591,7 @@
           <p:cNvPr id="10" name="">
             <a:extLst xmlns:a="http://schemas.openxmlformats.org/drawingml/2006/main">
               <a:ext uri="{FF2B5EF4-FFF2-40B4-BE49-F238E27FC236}">
-                <a16:creationId xmlns:a16="http://schemas.microsoft.com/office/drawing/2014/main" id="{4D9692D0-F510-4CFB-A79E-679A4808B9EC}"/>
+                <a16:creationId xmlns:a16="http://schemas.microsoft.com/office/drawing/2014/main" id="{8161070B-DA78-4D80-893B-83DD096CF61A}"/>
               </a:ext>
             </a:extLst>
           </p:cNvPr>
@@ -7747,7 +7747,7 @@
           <p:cNvPr id="11" name="">
             <a:extLst xmlns:a="http://schemas.openxmlformats.org/drawingml/2006/main">
               <a:ext uri="{FF2B5EF4-FFF2-40B4-BE49-F238E27FC236}">
-                <a16:creationId xmlns:a16="http://schemas.microsoft.com/office/drawing/2014/main" id="{6E5C068A-4D9C-443E-A1E9-868AF3000DDD}"/>
+                <a16:creationId xmlns:a16="http://schemas.microsoft.com/office/drawing/2014/main" id="{B825C2CD-8194-49FA-835B-08DD1EDA1262}"/>
               </a:ext>
             </a:extLst>
           </p:cNvPr>
@@ -7903,7 +7903,7 @@
           <p:cNvPr id="12" name="">
             <a:extLst xmlns:a="http://schemas.openxmlformats.org/drawingml/2006/main">
               <a:ext uri="{FF2B5EF4-FFF2-40B4-BE49-F238E27FC236}">
-                <a16:creationId xmlns:a16="http://schemas.microsoft.com/office/drawing/2014/main" id="{7773BE12-6DD0-4268-BBCE-EA8CC1C3257C}"/>
+                <a16:creationId xmlns:a16="http://schemas.microsoft.com/office/drawing/2014/main" id="{AA32BD9C-D073-4DE8-AB46-ED9C536D63D5}"/>
               </a:ext>
             </a:extLst>
           </p:cNvPr>
@@ -8057,7 +8057,7 @@
     </p:spTree>
     <p:extLst>
       <p:ext uri="{BB962C8B-B14F-4D97-AF65-F5344CB8AC3E}">
-        <p14:creationId xmlns:p14="http://schemas.microsoft.com/office/powerpoint/2010/main" val="1796852622"/>
+        <p14:creationId xmlns:p14="http://schemas.microsoft.com/office/powerpoint/2010/main" val="701979911"/>
       </p:ext>
     </p:extLst>
   </p:cSld>
@@ -8088,7 +8088,7 @@
           <p:cNvPr id="11" name="">
             <a:extLst xmlns:a="http://schemas.openxmlformats.org/drawingml/2006/main">
               <a:ext uri="{FF2B5EF4-FFF2-40B4-BE49-F238E27FC236}">
-                <a16:creationId xmlns:a16="http://schemas.microsoft.com/office/drawing/2014/main" id="{FC5E69EF-7F6B-480B-A34C-9E6B15191A57}"/>
+                <a16:creationId xmlns:a16="http://schemas.microsoft.com/office/drawing/2014/main" id="{9797CE18-9879-4D44-B332-805D08E48CEC}"/>
               </a:ext>
             </a:extLst>
           </p:cNvPr>
@@ -8244,7 +8244,7 @@
           <p:cNvPr id="2" name="">
             <a:extLst xmlns:a="http://schemas.openxmlformats.org/drawingml/2006/main">
               <a:ext uri="{FF2B5EF4-FFF2-40B4-BE49-F238E27FC236}">
-                <a16:creationId xmlns:a16="http://schemas.microsoft.com/office/drawing/2014/main" id="{45EBB8D3-5F86-4FC6-A9D4-861B6833B489}"/>
+                <a16:creationId xmlns:a16="http://schemas.microsoft.com/office/drawing/2014/main" id="{92FEAA0F-D637-4DA6-86D3-4C1C200ADBEC}"/>
               </a:ext>
             </a:extLst>
           </p:cNvPr>
@@ -8400,7 +8400,7 @@
           <p:cNvPr id="3" name="">
             <a:extLst xmlns:a="http://schemas.openxmlformats.org/drawingml/2006/main">
               <a:ext uri="{FF2B5EF4-FFF2-40B4-BE49-F238E27FC236}">
-                <a16:creationId xmlns:a16="http://schemas.microsoft.com/office/drawing/2014/main" id="{ED7F1B0E-864A-4A86-8A69-E16F71E523E4}"/>
+                <a16:creationId xmlns:a16="http://schemas.microsoft.com/office/drawing/2014/main" id="{170330D0-A2E8-4CBD-8816-750A68ECB2DA}"/>
               </a:ext>
             </a:extLst>
           </p:cNvPr>
@@ -8556,7 +8556,7 @@
           <p:cNvPr id="4" name="">
             <a:extLst xmlns:a="http://schemas.openxmlformats.org/drawingml/2006/main">
               <a:ext uri="{FF2B5EF4-FFF2-40B4-BE49-F238E27FC236}">
-                <a16:creationId xmlns:a16="http://schemas.microsoft.com/office/drawing/2014/main" id="{B998789E-4158-48B8-B0D4-8E6BCEFCA9E5}"/>
+                <a16:creationId xmlns:a16="http://schemas.microsoft.com/office/drawing/2014/main" id="{FDED7EA3-D742-4AAC-93B6-FFDF1F769F46}"/>
               </a:ext>
             </a:extLst>
           </p:cNvPr>
@@ -8712,7 +8712,7 @@
           <p:cNvPr id="5" name="">
             <a:extLst xmlns:a="http://schemas.openxmlformats.org/drawingml/2006/main">
               <a:ext uri="{FF2B5EF4-FFF2-40B4-BE49-F238E27FC236}">
-                <a16:creationId xmlns:a16="http://schemas.microsoft.com/office/drawing/2014/main" id="{A623D4B6-5ACF-417A-A01E-AD25FC45FDD1}"/>
+                <a16:creationId xmlns:a16="http://schemas.microsoft.com/office/drawing/2014/main" id="{135AADA9-9FCF-477E-8AF7-69EC9F6FFDA3}"/>
               </a:ext>
             </a:extLst>
           </p:cNvPr>
@@ -8868,7 +8868,7 @@
           <p:cNvPr id="6" name="">
             <a:extLst xmlns:a="http://schemas.openxmlformats.org/drawingml/2006/main">
               <a:ext uri="{FF2B5EF4-FFF2-40B4-BE49-F238E27FC236}">
-                <a16:creationId xmlns:a16="http://schemas.microsoft.com/office/drawing/2014/main" id="{F1F5865D-B2BC-4E22-AF05-03391309B743}"/>
+                <a16:creationId xmlns:a16="http://schemas.microsoft.com/office/drawing/2014/main" id="{6536D2CF-6C1B-45F2-BACA-7FF73CD7D502}"/>
               </a:ext>
             </a:extLst>
           </p:cNvPr>
@@ -9024,7 +9024,7 @@
           <p:cNvPr id="7" name="">
             <a:extLst xmlns:a="http://schemas.openxmlformats.org/drawingml/2006/main">
               <a:ext uri="{FF2B5EF4-FFF2-40B4-BE49-F238E27FC236}">
-                <a16:creationId xmlns:a16="http://schemas.microsoft.com/office/drawing/2014/main" id="{8701EE94-054F-4BBF-B76A-A05AC5A4DD14}"/>
+                <a16:creationId xmlns:a16="http://schemas.microsoft.com/office/drawing/2014/main" id="{FB20457E-E318-4038-9BB9-3C29BBCD8881}"/>
               </a:ext>
             </a:extLst>
           </p:cNvPr>
@@ -9203,7 +9203,7 @@
           <p:cNvPr id="8" name="">
             <a:extLst xmlns:a="http://schemas.openxmlformats.org/drawingml/2006/main">
               <a:ext uri="{FF2B5EF4-FFF2-40B4-BE49-F238E27FC236}">
-                <a16:creationId xmlns:a16="http://schemas.microsoft.com/office/drawing/2014/main" id="{37086370-AFE3-4D9F-ACDF-7A8BDC784F23}"/>
+                <a16:creationId xmlns:a16="http://schemas.microsoft.com/office/drawing/2014/main" id="{65214258-BFB8-47B9-A799-1C966B6E3A30}"/>
               </a:ext>
             </a:extLst>
           </p:cNvPr>
@@ -9359,7 +9359,7 @@
           <p:cNvPr id="9" name="">
             <a:extLst xmlns:a="http://schemas.openxmlformats.org/drawingml/2006/main">
               <a:ext uri="{FF2B5EF4-FFF2-40B4-BE49-F238E27FC236}">
-                <a16:creationId xmlns:a16="http://schemas.microsoft.com/office/drawing/2014/main" id="{BF9AF225-9AB2-4363-9A4D-45979525FD30}"/>
+                <a16:creationId xmlns:a16="http://schemas.microsoft.com/office/drawing/2014/main" id="{330F2D0B-7E09-42C7-AC02-49A276063C85}"/>
               </a:ext>
             </a:extLst>
           </p:cNvPr>
@@ -9515,7 +9515,7 @@
           <p:cNvPr id="10" name="">
             <a:extLst xmlns:a="http://schemas.openxmlformats.org/drawingml/2006/main">
               <a:ext uri="{FF2B5EF4-FFF2-40B4-BE49-F238E27FC236}">
-                <a16:creationId xmlns:a16="http://schemas.microsoft.com/office/drawing/2014/main" id="{B980CB73-C9BE-4CCA-87C4-20FAB7910EF6}"/>
+                <a16:creationId xmlns:a16="http://schemas.microsoft.com/office/drawing/2014/main" id="{BE1057BD-4F48-4D3E-B2A3-B8B62D348EC2}"/>
               </a:ext>
             </a:extLst>
           </p:cNvPr>
@@ -9669,7 +9669,7 @@
     </p:spTree>
     <p:extLst>
       <p:ext uri="{BB962C8B-B14F-4D97-AF65-F5344CB8AC3E}">
-        <p14:creationId xmlns:p14="http://schemas.microsoft.com/office/powerpoint/2010/main" val="2099940650"/>
+        <p14:creationId xmlns:p14="http://schemas.microsoft.com/office/powerpoint/2010/main" val="946239110"/>
       </p:ext>
     </p:extLst>
   </p:cSld>
@@ -9700,7 +9700,7 @@
           <p:cNvPr id="8" name="">
             <a:extLst xmlns:a="http://schemas.openxmlformats.org/drawingml/2006/main">
               <a:ext uri="{FF2B5EF4-FFF2-40B4-BE49-F238E27FC236}">
-                <a16:creationId xmlns:a16="http://schemas.microsoft.com/office/drawing/2014/main" id="{C290533B-4BA2-48E2-A2A8-6C29B0B25C48}"/>
+                <a16:creationId xmlns:a16="http://schemas.microsoft.com/office/drawing/2014/main" id="{C1DC3FC6-A7A5-4E61-A4BD-42E206F7C5B2}"/>
               </a:ext>
             </a:extLst>
           </p:cNvPr>
@@ -9856,7 +9856,7 @@
           <p:cNvPr id="2" name="">
             <a:extLst xmlns:a="http://schemas.openxmlformats.org/drawingml/2006/main">
               <a:ext uri="{FF2B5EF4-FFF2-40B4-BE49-F238E27FC236}">
-                <a16:creationId xmlns:a16="http://schemas.microsoft.com/office/drawing/2014/main" id="{1E40858A-06FD-4004-BAA9-344DB8A30CF1}"/>
+                <a16:creationId xmlns:a16="http://schemas.microsoft.com/office/drawing/2014/main" id="{06F57AED-9BAB-4A43-B892-3538667A8D57}"/>
               </a:ext>
             </a:extLst>
           </p:cNvPr>
@@ -10012,7 +10012,7 @@
           <p:cNvPr id="3" name="">
             <a:extLst xmlns:a="http://schemas.openxmlformats.org/drawingml/2006/main">
               <a:ext uri="{FF2B5EF4-FFF2-40B4-BE49-F238E27FC236}">
-                <a16:creationId xmlns:a16="http://schemas.microsoft.com/office/drawing/2014/main" id="{815DD5E0-F596-4B4C-9AF4-E36FFD3AEF77}"/>
+                <a16:creationId xmlns:a16="http://schemas.microsoft.com/office/drawing/2014/main" id="{64AFACE0-82C9-48A4-BA87-8DC91DCC16DB}"/>
               </a:ext>
             </a:extLst>
           </p:cNvPr>
@@ -10168,7 +10168,7 @@
           <p:cNvPr id="4" name="Chart">
             <a:extLst xmlns:a="http://schemas.openxmlformats.org/drawingml/2006/main">
               <a:ext uri="{FF2B5EF4-FFF2-40B4-BE49-F238E27FC236}">
-                <a16:creationId xmlns:a16="http://schemas.microsoft.com/office/drawing/2014/main" id="{88F5D391-06B8-4E5E-8ECB-CC655C8D3EFB}"/>
+                <a16:creationId xmlns:a16="http://schemas.microsoft.com/office/drawing/2014/main" id="{0ADEE8C6-048A-4894-8A6B-A18641ABD6C0}"/>
               </a:ext>
             </a:extLst>
           </p:cNvPr>
@@ -10181,7 +10181,7 @@
         </p:xfrm>
         <a:graphic xmlns:a="http://schemas.openxmlformats.org/drawingml/2006/main">
           <a:graphicData uri="http://schemas.openxmlformats.org/drawingml/2006/chart">
-            <c:chart xmlns:r="http://schemas.openxmlformats.org/officeDocument/2006/relationships" xmlns:c="http://schemas.openxmlformats.org/drawingml/2006/chart" r:id="R065d49aa193548ff"/>
+            <c:chart xmlns:r="http://schemas.openxmlformats.org/officeDocument/2006/relationships" xmlns:c="http://schemas.openxmlformats.org/drawingml/2006/chart" r:id="Rf76e57d17b8e4c59"/>
           </a:graphicData>
         </a:graphic>
       </p:graphicFrame>
@@ -10190,7 +10190,7 @@
           <p:cNvPr id="5" name="">
             <a:extLst xmlns:a="http://schemas.openxmlformats.org/drawingml/2006/main">
               <a:ext uri="{FF2B5EF4-FFF2-40B4-BE49-F238E27FC236}">
-                <a16:creationId xmlns:a16="http://schemas.microsoft.com/office/drawing/2014/main" id="{8F6D94F9-3C3E-4472-991F-0B50ADB5E23E}"/>
+                <a16:creationId xmlns:a16="http://schemas.microsoft.com/office/drawing/2014/main" id="{CCA0D03E-6B28-4266-9CBE-4DE45C3154E4}"/>
               </a:ext>
             </a:extLst>
           </p:cNvPr>
@@ -10346,7 +10346,7 @@
           <p:cNvPr id="6" name="">
             <a:extLst xmlns:a="http://schemas.openxmlformats.org/drawingml/2006/main">
               <a:ext uri="{FF2B5EF4-FFF2-40B4-BE49-F238E27FC236}">
-                <a16:creationId xmlns:a16="http://schemas.microsoft.com/office/drawing/2014/main" id="{1B36E9BD-95DB-4036-811D-5915F53F4520}"/>
+                <a16:creationId xmlns:a16="http://schemas.microsoft.com/office/drawing/2014/main" id="{27CFF991-AFF3-45C9-8E23-3880824918F0}"/>
               </a:ext>
             </a:extLst>
           </p:cNvPr>
@@ -10525,7 +10525,7 @@
           <p:cNvPr id="7" name="">
             <a:extLst xmlns:a="http://schemas.openxmlformats.org/drawingml/2006/main">
               <a:ext uri="{FF2B5EF4-FFF2-40B4-BE49-F238E27FC236}">
-                <a16:creationId xmlns:a16="http://schemas.microsoft.com/office/drawing/2014/main" id="{AF85A18C-27BE-4950-9EB4-548AF423B0BF}"/>
+                <a16:creationId xmlns:a16="http://schemas.microsoft.com/office/drawing/2014/main" id="{14BFC554-294F-4508-BB81-D9F8F1C0C353}"/>
               </a:ext>
             </a:extLst>
           </p:cNvPr>
@@ -10702,7 +10702,7 @@
     </p:spTree>
     <p:extLst>
       <p:ext uri="{BB962C8B-B14F-4D97-AF65-F5344CB8AC3E}">
-        <p14:creationId xmlns:p14="http://schemas.microsoft.com/office/powerpoint/2010/main" val="2001012140"/>
+        <p14:creationId xmlns:p14="http://schemas.microsoft.com/office/powerpoint/2010/main" val="1900707072"/>
       </p:ext>
     </p:extLst>
   </p:cSld>
@@ -10733,7 +10733,7 @@
           <p:cNvPr id="14" name="">
             <a:extLst xmlns:a="http://schemas.openxmlformats.org/drawingml/2006/main">
               <a:ext uri="{FF2B5EF4-FFF2-40B4-BE49-F238E27FC236}">
-                <a16:creationId xmlns:a16="http://schemas.microsoft.com/office/drawing/2014/main" id="{E75EF833-55B2-4445-982E-0B79F23C034F}"/>
+                <a16:creationId xmlns:a16="http://schemas.microsoft.com/office/drawing/2014/main" id="{19B1EC89-E836-486C-894F-EA2F570F8DE7}"/>
               </a:ext>
             </a:extLst>
           </p:cNvPr>
@@ -10889,7 +10889,7 @@
           <p:cNvPr id="2" name="">
             <a:extLst xmlns:a="http://schemas.openxmlformats.org/drawingml/2006/main">
               <a:ext uri="{FF2B5EF4-FFF2-40B4-BE49-F238E27FC236}">
-                <a16:creationId xmlns:a16="http://schemas.microsoft.com/office/drawing/2014/main" id="{01942E79-2744-4F8E-9041-532AAD8E16BA}"/>
+                <a16:creationId xmlns:a16="http://schemas.microsoft.com/office/drawing/2014/main" id="{A18D3502-0EA6-4EE6-AD8F-99E8551E9FBA}"/>
               </a:ext>
             </a:extLst>
           </p:cNvPr>
@@ -11045,7 +11045,7 @@
           <p:cNvPr id="3" name="">
             <a:extLst xmlns:a="http://schemas.openxmlformats.org/drawingml/2006/main">
               <a:ext uri="{FF2B5EF4-FFF2-40B4-BE49-F238E27FC236}">
-                <a16:creationId xmlns:a16="http://schemas.microsoft.com/office/drawing/2014/main" id="{F7AE06A1-A5F5-4FE1-AAC3-C4B20909D424}"/>
+                <a16:creationId xmlns:a16="http://schemas.microsoft.com/office/drawing/2014/main" id="{4C6D542B-B7FE-4FB9-87E2-8AD9EEBBB216}"/>
               </a:ext>
             </a:extLst>
           </p:cNvPr>
@@ -11201,7 +11201,7 @@
           <p:cNvPr id="4" name="">
             <a:extLst xmlns:a="http://schemas.openxmlformats.org/drawingml/2006/main">
               <a:ext uri="{FF2B5EF4-FFF2-40B4-BE49-F238E27FC236}">
-                <a16:creationId xmlns:a16="http://schemas.microsoft.com/office/drawing/2014/main" id="{E2A23BCA-B5CA-437D-B8AB-B9878BF271D4}"/>
+                <a16:creationId xmlns:a16="http://schemas.microsoft.com/office/drawing/2014/main" id="{07967FB1-688B-4AB9-B671-09CF38EF93A3}"/>
               </a:ext>
             </a:extLst>
           </p:cNvPr>
@@ -11357,7 +11357,7 @@
           <p:cNvPr id="5" name="">
             <a:extLst xmlns:a="http://schemas.openxmlformats.org/drawingml/2006/main">
               <a:ext uri="{FF2B5EF4-FFF2-40B4-BE49-F238E27FC236}">
-                <a16:creationId xmlns:a16="http://schemas.microsoft.com/office/drawing/2014/main" id="{1661ECA3-7AFA-4237-B1B8-E52A9248DC09}"/>
+                <a16:creationId xmlns:a16="http://schemas.microsoft.com/office/drawing/2014/main" id="{D567019F-E07B-46C1-B0E1-0427277A7286}"/>
               </a:ext>
             </a:extLst>
           </p:cNvPr>
@@ -11513,7 +11513,7 @@
           <p:cNvPr id="6" name="">
             <a:extLst xmlns:a="http://schemas.openxmlformats.org/drawingml/2006/main">
               <a:ext uri="{FF2B5EF4-FFF2-40B4-BE49-F238E27FC236}">
-                <a16:creationId xmlns:a16="http://schemas.microsoft.com/office/drawing/2014/main" id="{EA9A2B4B-15C6-4DCF-8C2C-D2C91BC9ADC4}"/>
+                <a16:creationId xmlns:a16="http://schemas.microsoft.com/office/drawing/2014/main" id="{2894E38E-2E40-4111-B0C1-1F4FF56D9266}"/>
               </a:ext>
             </a:extLst>
           </p:cNvPr>
@@ -11669,7 +11669,7 @@
           <p:cNvPr id="7" name="">
             <a:extLst xmlns:a="http://schemas.openxmlformats.org/drawingml/2006/main">
               <a:ext uri="{FF2B5EF4-FFF2-40B4-BE49-F238E27FC236}">
-                <a16:creationId xmlns:a16="http://schemas.microsoft.com/office/drawing/2014/main" id="{2EA0E6A8-5442-4ADE-ACBE-4402372C7F74}"/>
+                <a16:creationId xmlns:a16="http://schemas.microsoft.com/office/drawing/2014/main" id="{D616186F-52F6-4EDD-8040-53E47E75D5E2}"/>
               </a:ext>
             </a:extLst>
           </p:cNvPr>
@@ -11825,7 +11825,7 @@
           <p:cNvPr id="8" name="">
             <a:extLst xmlns:a="http://schemas.openxmlformats.org/drawingml/2006/main">
               <a:ext uri="{FF2B5EF4-FFF2-40B4-BE49-F238E27FC236}">
-                <a16:creationId xmlns:a16="http://schemas.microsoft.com/office/drawing/2014/main" id="{56B6989D-3647-4D38-9A75-42E1229CE1F3}"/>
+                <a16:creationId xmlns:a16="http://schemas.microsoft.com/office/drawing/2014/main" id="{7753701F-73AF-4493-8BEA-5EE8A670B7DE}"/>
               </a:ext>
             </a:extLst>
           </p:cNvPr>
@@ -11981,7 +11981,7 @@
           <p:cNvPr id="9" name="">
             <a:extLst xmlns:a="http://schemas.openxmlformats.org/drawingml/2006/main">
               <a:ext uri="{FF2B5EF4-FFF2-40B4-BE49-F238E27FC236}">
-                <a16:creationId xmlns:a16="http://schemas.microsoft.com/office/drawing/2014/main" id="{0D54AB02-1801-4CD6-8B20-609875D5F325}"/>
+                <a16:creationId xmlns:a16="http://schemas.microsoft.com/office/drawing/2014/main" id="{A683B709-0878-4EB8-8F2F-9A263E9CA25D}"/>
               </a:ext>
             </a:extLst>
           </p:cNvPr>
@@ -12137,7 +12137,7 @@
           <p:cNvPr id="10" name="">
             <a:extLst xmlns:a="http://schemas.openxmlformats.org/drawingml/2006/main">
               <a:ext uri="{FF2B5EF4-FFF2-40B4-BE49-F238E27FC236}">
-                <a16:creationId xmlns:a16="http://schemas.microsoft.com/office/drawing/2014/main" id="{5641B575-191C-428D-85BC-5BD642852324}"/>
+                <a16:creationId xmlns:a16="http://schemas.microsoft.com/office/drawing/2014/main" id="{71F73160-3406-4691-9EAD-731025726290}"/>
               </a:ext>
             </a:extLst>
           </p:cNvPr>
@@ -12293,7 +12293,7 @@
           <p:cNvPr id="11" name="">
             <a:extLst xmlns:a="http://schemas.openxmlformats.org/drawingml/2006/main">
               <a:ext uri="{FF2B5EF4-FFF2-40B4-BE49-F238E27FC236}">
-                <a16:creationId xmlns:a16="http://schemas.microsoft.com/office/drawing/2014/main" id="{AD042B90-6575-4EBE-9AFC-EF913BDBC5AA}"/>
+                <a16:creationId xmlns:a16="http://schemas.microsoft.com/office/drawing/2014/main" id="{A880508B-4EB2-48DB-809C-009A2C8D6DE2}"/>
               </a:ext>
             </a:extLst>
           </p:cNvPr>
@@ -12449,7 +12449,7 @@
           <p:cNvPr id="12" name="">
             <a:extLst xmlns:a="http://schemas.openxmlformats.org/drawingml/2006/main">
               <a:ext uri="{FF2B5EF4-FFF2-40B4-BE49-F238E27FC236}">
-                <a16:creationId xmlns:a16="http://schemas.microsoft.com/office/drawing/2014/main" id="{7B1806F2-2845-477F-85C7-72909F59CAC6}"/>
+                <a16:creationId xmlns:a16="http://schemas.microsoft.com/office/drawing/2014/main" id="{EF681173-4693-442F-838A-0A1C2A20712B}"/>
               </a:ext>
             </a:extLst>
           </p:cNvPr>
@@ -12605,7 +12605,7 @@
           <p:cNvPr id="13" name="">
             <a:extLst xmlns:a="http://schemas.openxmlformats.org/drawingml/2006/main">
               <a:ext uri="{FF2B5EF4-FFF2-40B4-BE49-F238E27FC236}">
-                <a16:creationId xmlns:a16="http://schemas.microsoft.com/office/drawing/2014/main" id="{CB699823-1925-479A-90DC-E5ECFC6FCD01}"/>
+                <a16:creationId xmlns:a16="http://schemas.microsoft.com/office/drawing/2014/main" id="{A11F2B77-334F-4858-A9DE-061CD12F46B9}"/>
               </a:ext>
             </a:extLst>
           </p:cNvPr>
@@ -12759,7 +12759,7 @@
     </p:spTree>
     <p:extLst>
       <p:ext uri="{BB962C8B-B14F-4D97-AF65-F5344CB8AC3E}">
-        <p14:creationId xmlns:p14="http://schemas.microsoft.com/office/powerpoint/2010/main" val="1367163317"/>
+        <p14:creationId xmlns:p14="http://schemas.microsoft.com/office/powerpoint/2010/main" val="1549640490"/>
       </p:ext>
     </p:extLst>
   </p:cSld>
@@ -12790,7 +12790,7 @@
           <p:cNvPr id="9" name="">
             <a:extLst xmlns:a="http://schemas.openxmlformats.org/drawingml/2006/main">
               <a:ext uri="{FF2B5EF4-FFF2-40B4-BE49-F238E27FC236}">
-                <a16:creationId xmlns:a16="http://schemas.microsoft.com/office/drawing/2014/main" id="{0F1D303D-84B3-43E3-B840-9C274677910F}"/>
+                <a16:creationId xmlns:a16="http://schemas.microsoft.com/office/drawing/2014/main" id="{AD1ECBE1-9BA1-472D-8F6E-A91727CFDDDA}"/>
               </a:ext>
             </a:extLst>
           </p:cNvPr>
@@ -12946,7 +12946,7 @@
           <p:cNvPr id="2" name="">
             <a:extLst xmlns:a="http://schemas.openxmlformats.org/drawingml/2006/main">
               <a:ext uri="{FF2B5EF4-FFF2-40B4-BE49-F238E27FC236}">
-                <a16:creationId xmlns:a16="http://schemas.microsoft.com/office/drawing/2014/main" id="{560E6860-7EF4-4FCD-8512-F3D3B473B75D}"/>
+                <a16:creationId xmlns:a16="http://schemas.microsoft.com/office/drawing/2014/main" id="{9567EB34-D2D3-45A5-BBAF-AD89626DAD36}"/>
               </a:ext>
             </a:extLst>
           </p:cNvPr>
@@ -13102,7 +13102,7 @@
           <p:cNvPr id="3" name="">
             <a:extLst xmlns:a="http://schemas.openxmlformats.org/drawingml/2006/main">
               <a:ext uri="{FF2B5EF4-FFF2-40B4-BE49-F238E27FC236}">
-                <a16:creationId xmlns:a16="http://schemas.microsoft.com/office/drawing/2014/main" id="{4D7F0791-C244-4065-93B3-694E795CE97F}"/>
+                <a16:creationId xmlns:a16="http://schemas.microsoft.com/office/drawing/2014/main" id="{9A5B77F3-C205-49BC-AAEB-86CC4852739E}"/>
               </a:ext>
             </a:extLst>
           </p:cNvPr>
@@ -13258,7 +13258,7 @@
           <p:cNvPr id="4" name="">
             <a:extLst xmlns:a="http://schemas.openxmlformats.org/drawingml/2006/main">
               <a:ext uri="{FF2B5EF4-FFF2-40B4-BE49-F238E27FC236}">
-                <a16:creationId xmlns:a16="http://schemas.microsoft.com/office/drawing/2014/main" id="{20FD625F-BDE0-45BB-AF49-1EA918352098}"/>
+                <a16:creationId xmlns:a16="http://schemas.microsoft.com/office/drawing/2014/main" id="{2629E978-2088-4F70-A2FD-9BE585043972}"/>
               </a:ext>
             </a:extLst>
           </p:cNvPr>
@@ -13414,7 +13414,7 @@
           <p:cNvPr id="5" name="">
             <a:extLst xmlns:a="http://schemas.openxmlformats.org/drawingml/2006/main">
               <a:ext uri="{FF2B5EF4-FFF2-40B4-BE49-F238E27FC236}">
-                <a16:creationId xmlns:a16="http://schemas.microsoft.com/office/drawing/2014/main" id="{322A28CF-7E8D-4D62-911F-F470DF0D0B45}"/>
+                <a16:creationId xmlns:a16="http://schemas.microsoft.com/office/drawing/2014/main" id="{863B8CB6-055D-4A84-8079-51CDBE1FFA49}"/>
               </a:ext>
             </a:extLst>
           </p:cNvPr>
@@ -13593,7 +13593,7 @@
           <p:cNvPr id="6" name="">
             <a:extLst xmlns:a="http://schemas.openxmlformats.org/drawingml/2006/main">
               <a:ext uri="{FF2B5EF4-FFF2-40B4-BE49-F238E27FC236}">
-                <a16:creationId xmlns:a16="http://schemas.microsoft.com/office/drawing/2014/main" id="{85F6F714-5488-4A4A-BF8B-BB914A3F0443}"/>
+                <a16:creationId xmlns:a16="http://schemas.microsoft.com/office/drawing/2014/main" id="{5D6CF9DF-A602-4C82-BAD6-BBB377BFA8DD}"/>
               </a:ext>
             </a:extLst>
           </p:cNvPr>
@@ -13749,7 +13749,7 @@
           <p:cNvPr id="7" name="">
             <a:extLst xmlns:a="http://schemas.openxmlformats.org/drawingml/2006/main">
               <a:ext uri="{FF2B5EF4-FFF2-40B4-BE49-F238E27FC236}">
-                <a16:creationId xmlns:a16="http://schemas.microsoft.com/office/drawing/2014/main" id="{0D4FFC44-8CDB-4816-8574-77538A4EF596}"/>
+                <a16:creationId xmlns:a16="http://schemas.microsoft.com/office/drawing/2014/main" id="{6FADDBE1-F4A9-4A84-8D83-CAB1EB5EC6EB}"/>
               </a:ext>
             </a:extLst>
           </p:cNvPr>
@@ -13928,7 +13928,7 @@
           <p:cNvPr id="8" name="">
             <a:extLst xmlns:a="http://schemas.openxmlformats.org/drawingml/2006/main">
               <a:ext uri="{FF2B5EF4-FFF2-40B4-BE49-F238E27FC236}">
-                <a16:creationId xmlns:a16="http://schemas.microsoft.com/office/drawing/2014/main" id="{CF1C42DE-C841-4DCA-8485-7ACEBE6A2F30}"/>
+                <a16:creationId xmlns:a16="http://schemas.microsoft.com/office/drawing/2014/main" id="{26EDB5A4-52CC-4C42-B368-412F195645C7}"/>
               </a:ext>
             </a:extLst>
           </p:cNvPr>
@@ -14082,7 +14082,7 @@
     </p:spTree>
     <p:extLst>
       <p:ext uri="{BB962C8B-B14F-4D97-AF65-F5344CB8AC3E}">
-        <p14:creationId xmlns:p14="http://schemas.microsoft.com/office/powerpoint/2010/main" val="383723617"/>
+        <p14:creationId xmlns:p14="http://schemas.microsoft.com/office/powerpoint/2010/main" val="1935722940"/>
       </p:ext>
     </p:extLst>
   </p:cSld>
@@ -14113,7 +14113,7 @@
           <p:cNvPr id="6" name="">
             <a:extLst xmlns:a="http://schemas.openxmlformats.org/drawingml/2006/main">
               <a:ext uri="{FF2B5EF4-FFF2-40B4-BE49-F238E27FC236}">
-                <a16:creationId xmlns:a16="http://schemas.microsoft.com/office/drawing/2014/main" id="{7A222B53-9A83-43CD-A4EF-8A659AC6827F}"/>
+                <a16:creationId xmlns:a16="http://schemas.microsoft.com/office/drawing/2014/main" id="{13FE2E58-95AF-43C9-A0DE-CB582FD0B005}"/>
               </a:ext>
             </a:extLst>
           </p:cNvPr>
@@ -14269,7 +14269,7 @@
           <p:cNvPr id="2" name="">
             <a:extLst xmlns:a="http://schemas.openxmlformats.org/drawingml/2006/main">
               <a:ext uri="{FF2B5EF4-FFF2-40B4-BE49-F238E27FC236}">
-                <a16:creationId xmlns:a16="http://schemas.microsoft.com/office/drawing/2014/main" id="{4445EC6A-7847-48B2-87A2-B1180169421C}"/>
+                <a16:creationId xmlns:a16="http://schemas.microsoft.com/office/drawing/2014/main" id="{CB3D2174-9B0C-4915-8AD7-A4E822D0A710}"/>
               </a:ext>
             </a:extLst>
           </p:cNvPr>
@@ -14425,7 +14425,7 @@
           <p:cNvPr id="3" name="">
             <a:extLst xmlns:a="http://schemas.openxmlformats.org/drawingml/2006/main">
               <a:ext uri="{FF2B5EF4-FFF2-40B4-BE49-F238E27FC236}">
-                <a16:creationId xmlns:a16="http://schemas.microsoft.com/office/drawing/2014/main" id="{EDC6822C-EA1A-4889-B2DF-7EB5E03F9589}"/>
+                <a16:creationId xmlns:a16="http://schemas.microsoft.com/office/drawing/2014/main" id="{24DDD180-158C-450B-AF82-A4D336E73AEC}"/>
               </a:ext>
             </a:extLst>
           </p:cNvPr>
@@ -14581,7 +14581,7 @@
           <p:cNvPr id="4" name="">
             <a:extLst xmlns:a="http://schemas.openxmlformats.org/drawingml/2006/main">
               <a:ext uri="{FF2B5EF4-FFF2-40B4-BE49-F238E27FC236}">
-                <a16:creationId xmlns:a16="http://schemas.microsoft.com/office/drawing/2014/main" id="{89DA21DE-1B02-4F81-AE33-16463E6D1D12}"/>
+                <a16:creationId xmlns:a16="http://schemas.microsoft.com/office/drawing/2014/main" id="{F857B278-EED5-4C1B-B174-2E01E803173F}"/>
               </a:ext>
             </a:extLst>
           </p:cNvPr>
@@ -14906,7 +14906,7 @@
           <p:cNvPr id="5" name="">
             <a:extLst xmlns:a="http://schemas.openxmlformats.org/drawingml/2006/main">
               <a:ext uri="{FF2B5EF4-FFF2-40B4-BE49-F238E27FC236}">
-                <a16:creationId xmlns:a16="http://schemas.microsoft.com/office/drawing/2014/main" id="{859A335B-B6EA-4E47-9401-410FCD61D7F8}"/>
+                <a16:creationId xmlns:a16="http://schemas.microsoft.com/office/drawing/2014/main" id="{EB482E5E-D2B2-4317-87E9-5D6B7EE1C74D}"/>
               </a:ext>
             </a:extLst>
           </p:cNvPr>
@@ -15060,7 +15060,7 @@
     </p:spTree>
     <p:extLst>
       <p:ext uri="{BB962C8B-B14F-4D97-AF65-F5344CB8AC3E}">
-        <p14:creationId xmlns:p14="http://schemas.microsoft.com/office/powerpoint/2010/main" val="454687929"/>
+        <p14:creationId xmlns:p14="http://schemas.microsoft.com/office/powerpoint/2010/main" val="631532564"/>
       </p:ext>
     </p:extLst>
   </p:cSld>
@@ -15091,7 +15091,7 @@
           <p:cNvPr id="7" name="">
             <a:extLst xmlns:a="http://schemas.openxmlformats.org/drawingml/2006/main">
               <a:ext uri="{FF2B5EF4-FFF2-40B4-BE49-F238E27FC236}">
-                <a16:creationId xmlns:a16="http://schemas.microsoft.com/office/drawing/2014/main" id="{665487C4-427D-4BC4-85CD-11DE36BB2323}"/>
+                <a16:creationId xmlns:a16="http://schemas.microsoft.com/office/drawing/2014/main" id="{8FA0D0DC-69E6-43A4-9B30-2F549256CE26}"/>
               </a:ext>
             </a:extLst>
           </p:cNvPr>
@@ -15247,7 +15247,7 @@
           <p:cNvPr id="2" name="">
             <a:extLst xmlns:a="http://schemas.openxmlformats.org/drawingml/2006/main">
               <a:ext uri="{FF2B5EF4-FFF2-40B4-BE49-F238E27FC236}">
-                <a16:creationId xmlns:a16="http://schemas.microsoft.com/office/drawing/2014/main" id="{C1DEC567-ABBE-4285-9372-0172B685062D}"/>
+                <a16:creationId xmlns:a16="http://schemas.microsoft.com/office/drawing/2014/main" id="{567D167A-0109-49D2-9F4B-D05DA7972208}"/>
               </a:ext>
             </a:extLst>
           </p:cNvPr>
@@ -15403,7 +15403,7 @@
           <p:cNvPr id="3" name="">
             <a:extLst xmlns:a="http://schemas.openxmlformats.org/drawingml/2006/main">
               <a:ext uri="{FF2B5EF4-FFF2-40B4-BE49-F238E27FC236}">
-                <a16:creationId xmlns:a16="http://schemas.microsoft.com/office/drawing/2014/main" id="{DD19792E-2A29-410B-8DBB-32D73FA649AE}"/>
+                <a16:creationId xmlns:a16="http://schemas.microsoft.com/office/drawing/2014/main" id="{DC90FA0E-0F79-4323-9BE6-8620EB1A1189}"/>
               </a:ext>
             </a:extLst>
           </p:cNvPr>
@@ -15559,7 +15559,7 @@
           <p:cNvPr id="4" name="">
             <a:extLst xmlns:a="http://schemas.openxmlformats.org/drawingml/2006/main">
               <a:ext uri="{FF2B5EF4-FFF2-40B4-BE49-F238E27FC236}">
-                <a16:creationId xmlns:a16="http://schemas.microsoft.com/office/drawing/2014/main" id="{CDC22919-E131-4696-96C6-988AFAC2396F}"/>
+                <a16:creationId xmlns:a16="http://schemas.microsoft.com/office/drawing/2014/main" id="{2712BE31-5C28-4CCA-9972-FCE30C367562}"/>
               </a:ext>
             </a:extLst>
           </p:cNvPr>
@@ -15884,7 +15884,7 @@
           <p:cNvPr id="5" name="">
             <a:extLst xmlns:a="http://schemas.openxmlformats.org/drawingml/2006/main">
               <a:ext uri="{FF2B5EF4-FFF2-40B4-BE49-F238E27FC236}">
-                <a16:creationId xmlns:a16="http://schemas.microsoft.com/office/drawing/2014/main" id="{5827B85A-AB6D-4EA4-8358-0CFF0EB9CA69}"/>
+                <a16:creationId xmlns:a16="http://schemas.microsoft.com/office/drawing/2014/main" id="{356CFE5F-9956-4F16-B5CC-6A7E82AE7A9E}"/>
               </a:ext>
             </a:extLst>
           </p:cNvPr>
@@ -16063,7 +16063,7 @@
           <p:cNvPr id="6" name="Chart">
             <a:extLst xmlns:a="http://schemas.openxmlformats.org/drawingml/2006/main">
               <a:ext uri="{FF2B5EF4-FFF2-40B4-BE49-F238E27FC236}">
-                <a16:creationId xmlns:a16="http://schemas.microsoft.com/office/drawing/2014/main" id="{43A832BB-98C6-4227-88C2-8A87DE4AEF66}"/>
+                <a16:creationId xmlns:a16="http://schemas.microsoft.com/office/drawing/2014/main" id="{F2899072-5FBA-4A61-9BBC-4BD8279548FA}"/>
               </a:ext>
             </a:extLst>
           </p:cNvPr>
@@ -16076,14 +16076,14 @@
         </p:xfrm>
         <a:graphic xmlns:a="http://schemas.openxmlformats.org/drawingml/2006/main">
           <a:graphicData uri="http://schemas.openxmlformats.org/drawingml/2006/chart">
-            <c:chart xmlns:r="http://schemas.openxmlformats.org/officeDocument/2006/relationships" xmlns:c="http://schemas.openxmlformats.org/drawingml/2006/chart" r:id="Rb5df8ca45ec847c8"/>
+            <c:chart xmlns:r="http://schemas.openxmlformats.org/officeDocument/2006/relationships" xmlns:c="http://schemas.openxmlformats.org/drawingml/2006/chart" r:id="Rbaeac0f128ec4592"/>
           </a:graphicData>
         </a:graphic>
       </p:graphicFrame>
     </p:spTree>
     <p:extLst>
       <p:ext uri="{BB962C8B-B14F-4D97-AF65-F5344CB8AC3E}">
-        <p14:creationId xmlns:p14="http://schemas.microsoft.com/office/powerpoint/2010/main" val="506260263"/>
+        <p14:creationId xmlns:p14="http://schemas.microsoft.com/office/powerpoint/2010/main" val="770327542"/>
       </p:ext>
     </p:extLst>
   </p:cSld>
@@ -16114,7 +16114,7 @@
           <p:cNvPr id="7" name="">
             <a:extLst xmlns:a="http://schemas.openxmlformats.org/drawingml/2006/main">
               <a:ext uri="{FF2B5EF4-FFF2-40B4-BE49-F238E27FC236}">
-                <a16:creationId xmlns:a16="http://schemas.microsoft.com/office/drawing/2014/main" id="{F7462F61-28FA-46CF-80F8-13F7EEEA3E6B}"/>
+                <a16:creationId xmlns:a16="http://schemas.microsoft.com/office/drawing/2014/main" id="{DF73C405-3287-45A8-9788-B031D3780E19}"/>
               </a:ext>
             </a:extLst>
           </p:cNvPr>
@@ -16270,7 +16270,7 @@
           <p:cNvPr id="2" name="">
             <a:extLst xmlns:a="http://schemas.openxmlformats.org/drawingml/2006/main">
               <a:ext uri="{FF2B5EF4-FFF2-40B4-BE49-F238E27FC236}">
-                <a16:creationId xmlns:a16="http://schemas.microsoft.com/office/drawing/2014/main" id="{B66CDC50-7152-42EB-9C98-F9E69411706D}"/>
+                <a16:creationId xmlns:a16="http://schemas.microsoft.com/office/drawing/2014/main" id="{B26A62C3-6DB8-4110-B1E4-02F7F16D7E3F}"/>
               </a:ext>
             </a:extLst>
           </p:cNvPr>
@@ -16426,7 +16426,7 @@
           <p:cNvPr id="3" name="">
             <a:extLst xmlns:a="http://schemas.openxmlformats.org/drawingml/2006/main">
               <a:ext uri="{FF2B5EF4-FFF2-40B4-BE49-F238E27FC236}">
-                <a16:creationId xmlns:a16="http://schemas.microsoft.com/office/drawing/2014/main" id="{94BD108F-19BF-4C39-8268-CF9B5A4909F6}"/>
+                <a16:creationId xmlns:a16="http://schemas.microsoft.com/office/drawing/2014/main" id="{EE8DE491-DBBC-4B63-B18B-988271BF578B}"/>
               </a:ext>
             </a:extLst>
           </p:cNvPr>
@@ -16582,7 +16582,7 @@
           <p:cNvPr id="4" name="Chart">
             <a:extLst xmlns:a="http://schemas.openxmlformats.org/drawingml/2006/main">
               <a:ext uri="{FF2B5EF4-FFF2-40B4-BE49-F238E27FC236}">
-                <a16:creationId xmlns:a16="http://schemas.microsoft.com/office/drawing/2014/main" id="{2E38D8BE-8599-4EB4-9B2B-25CFF1AFF248}"/>
+                <a16:creationId xmlns:a16="http://schemas.microsoft.com/office/drawing/2014/main" id="{E9D8515D-8BD5-4B95-A75B-FA4A275891A9}"/>
               </a:ext>
             </a:extLst>
           </p:cNvPr>
@@ -16595,7 +16595,7 @@
         </p:xfrm>
         <a:graphic xmlns:a="http://schemas.openxmlformats.org/drawingml/2006/main">
           <a:graphicData uri="http://schemas.openxmlformats.org/drawingml/2006/chart">
-            <c:chart xmlns:r="http://schemas.openxmlformats.org/officeDocument/2006/relationships" xmlns:c="http://schemas.openxmlformats.org/drawingml/2006/chart" r:id="Rd2f5ba231e5940d8"/>
+            <c:chart xmlns:r="http://schemas.openxmlformats.org/officeDocument/2006/relationships" xmlns:c="http://schemas.openxmlformats.org/drawingml/2006/chart" r:id="R2acf16e56b374595"/>
           </a:graphicData>
         </a:graphic>
       </p:graphicFrame>
@@ -16604,7 +16604,7 @@
           <p:cNvPr id="5" name="">
             <a:extLst xmlns:a="http://schemas.openxmlformats.org/drawingml/2006/main">
               <a:ext uri="{FF2B5EF4-FFF2-40B4-BE49-F238E27FC236}">
-                <a16:creationId xmlns:a16="http://schemas.microsoft.com/office/drawing/2014/main" id="{0DD0B6EC-4DE1-4713-893F-CAA7CCCC9745}"/>
+                <a16:creationId xmlns:a16="http://schemas.microsoft.com/office/drawing/2014/main" id="{3552698B-CF3B-44BE-B2A9-106AD2694E76}"/>
               </a:ext>
             </a:extLst>
           </p:cNvPr>
@@ -16832,7 +16832,7 @@
           <p:cNvPr id="6" name="">
             <a:extLst xmlns:a="http://schemas.openxmlformats.org/drawingml/2006/main">
               <a:ext uri="{FF2B5EF4-FFF2-40B4-BE49-F238E27FC236}">
-                <a16:creationId xmlns:a16="http://schemas.microsoft.com/office/drawing/2014/main" id="{2869EBCB-7DB8-4696-83AF-D40B3D25B49C}"/>
+                <a16:creationId xmlns:a16="http://schemas.microsoft.com/office/drawing/2014/main" id="{34C7D232-7085-4AF0-82D7-C075ED2880B9}"/>
               </a:ext>
             </a:extLst>
           </p:cNvPr>
@@ -16986,7 +16986,7 @@
     </p:spTree>
     <p:extLst>
       <p:ext uri="{BB962C8B-B14F-4D97-AF65-F5344CB8AC3E}">
-        <p14:creationId xmlns:p14="http://schemas.microsoft.com/office/powerpoint/2010/main" val="313239343"/>
+        <p14:creationId xmlns:p14="http://schemas.microsoft.com/office/powerpoint/2010/main" val="709446723"/>
       </p:ext>
     </p:extLst>
   </p:cSld>
@@ -17017,7 +17017,7 @@
           <p:cNvPr id="7" name="">
             <a:extLst xmlns:a="http://schemas.openxmlformats.org/drawingml/2006/main">
               <a:ext uri="{FF2B5EF4-FFF2-40B4-BE49-F238E27FC236}">
-                <a16:creationId xmlns:a16="http://schemas.microsoft.com/office/drawing/2014/main" id="{D1705AC7-FA07-44A1-B3E1-8E76D4AB1A60}"/>
+                <a16:creationId xmlns:a16="http://schemas.microsoft.com/office/drawing/2014/main" id="{A09721D4-F70C-40A9-862A-23330CE3BE1B}"/>
               </a:ext>
             </a:extLst>
           </p:cNvPr>
@@ -17173,7 +17173,7 @@
           <p:cNvPr id="2" name="">
             <a:extLst xmlns:a="http://schemas.openxmlformats.org/drawingml/2006/main">
               <a:ext uri="{FF2B5EF4-FFF2-40B4-BE49-F238E27FC236}">
-                <a16:creationId xmlns:a16="http://schemas.microsoft.com/office/drawing/2014/main" id="{DB65FE8F-898E-4750-AB20-EA2457D56667}"/>
+                <a16:creationId xmlns:a16="http://schemas.microsoft.com/office/drawing/2014/main" id="{1BC9E46F-9DA6-443F-A192-692A6F586BE6}"/>
               </a:ext>
             </a:extLst>
           </p:cNvPr>
@@ -17329,7 +17329,7 @@
           <p:cNvPr id="3" name="">
             <a:extLst xmlns:a="http://schemas.openxmlformats.org/drawingml/2006/main">
               <a:ext uri="{FF2B5EF4-FFF2-40B4-BE49-F238E27FC236}">
-                <a16:creationId xmlns:a16="http://schemas.microsoft.com/office/drawing/2014/main" id="{439B29A4-8545-4D4A-BF93-A55F3BE6D5ED}"/>
+                <a16:creationId xmlns:a16="http://schemas.microsoft.com/office/drawing/2014/main" id="{286F8A9D-48BF-4435-A67E-E63D54619A4B}"/>
               </a:ext>
             </a:extLst>
           </p:cNvPr>
@@ -17485,7 +17485,7 @@
           <p:cNvPr id="4" name="">
             <a:extLst xmlns:a="http://schemas.openxmlformats.org/drawingml/2006/main">
               <a:ext uri="{FF2B5EF4-FFF2-40B4-BE49-F238E27FC236}">
-                <a16:creationId xmlns:a16="http://schemas.microsoft.com/office/drawing/2014/main" id="{A21BFA06-590D-46E7-92F5-EAEF9A2CF0D1}"/>
+                <a16:creationId xmlns:a16="http://schemas.microsoft.com/office/drawing/2014/main" id="{194C8E84-C4FD-46C9-9A06-B90C986B270E}"/>
               </a:ext>
             </a:extLst>
           </p:cNvPr>
@@ -17641,7 +17641,7 @@
           <p:cNvPr id="5" name="">
             <a:extLst xmlns:a="http://schemas.openxmlformats.org/drawingml/2006/main">
               <a:ext uri="{FF2B5EF4-FFF2-40B4-BE49-F238E27FC236}">
-                <a16:creationId xmlns:a16="http://schemas.microsoft.com/office/drawing/2014/main" id="{6A5F89C0-BDD9-485A-85CF-0FD6CCCEC880}"/>
+                <a16:creationId xmlns:a16="http://schemas.microsoft.com/office/drawing/2014/main" id="{13CCB9A6-CAEE-450E-B384-4DBC5353B65A}"/>
               </a:ext>
             </a:extLst>
           </p:cNvPr>
@@ -17869,7 +17869,7 @@
           <p:cNvPr id="6" name="">
             <a:extLst xmlns:a="http://schemas.openxmlformats.org/drawingml/2006/main">
               <a:ext uri="{FF2B5EF4-FFF2-40B4-BE49-F238E27FC236}">
-                <a16:creationId xmlns:a16="http://schemas.microsoft.com/office/drawing/2014/main" id="{B9024111-297F-41F4-B220-851BD57F7D64}"/>
+                <a16:creationId xmlns:a16="http://schemas.microsoft.com/office/drawing/2014/main" id="{29207865-C6BC-4485-940B-9DA8ED9409BA}"/>
               </a:ext>
             </a:extLst>
           </p:cNvPr>
@@ -18023,7 +18023,7 @@
     </p:spTree>
     <p:extLst>
       <p:ext uri="{BB962C8B-B14F-4D97-AF65-F5344CB8AC3E}">
-        <p14:creationId xmlns:p14="http://schemas.microsoft.com/office/powerpoint/2010/main" val="1047676517"/>
+        <p14:creationId xmlns:p14="http://schemas.microsoft.com/office/powerpoint/2010/main" val="7787791"/>
       </p:ext>
     </p:extLst>
   </p:cSld>

</xml_diff>